<commit_message>
Improved based on feedback from first tream
</commit_message>
<xml_diff>
--- a/docs/DI.pptx
+++ b/docs/DI.pptx
@@ -1998,7 +1998,7 @@
           <a:p>
             <a:fld id="{69EE0E52-9FA9-4B42-B8AF-6D441E01BAE7}" type="datetimeFigureOut">
               <a:rPr lang="nl-NL"/>
-              <a:t>3-2-2026</a:t>
+              <a:t>30-3-2026</a:t>
             </a:fld>
             <a:endParaRPr lang="nl-NL"/>
           </a:p>
@@ -2163,7 +2163,7 @@
           <a:p>
             <a:fld id="{3077C25E-6688-43F9-8010-6219F97B2F0D}" type="datetimeFigureOut">
               <a:rPr lang="nl-NL"/>
-              <a:t>3-2-2026</a:t>
+              <a:t>30-3-2026</a:t>
             </a:fld>
             <a:endParaRPr lang="nl-NL"/>
           </a:p>
@@ -2601,7 +2601,74 @@
           <a:bodyPr/>
           <a:lstStyle/>
           <a:p>
-            <a:endParaRPr lang="nl-NL" dirty="0"/>
+            <a:pPr marL="0" marR="0" lvl="0" indent="0" algn="l" defTabSz="914400" rtl="0" eaLnBrk="1" fontAlgn="auto" latinLnBrk="0" hangingPunct="1">
+              <a:lnSpc>
+                <a:spcPct val="100000"/>
+              </a:lnSpc>
+              <a:spcBef>
+                <a:spcPts val="0"/>
+              </a:spcBef>
+              <a:spcAft>
+                <a:spcPts val="0"/>
+              </a:spcAft>
+              <a:buClrTx/>
+              <a:buSzTx/>
+              <a:buFontTx/>
+              <a:buNone/>
+              <a:tabLst/>
+              <a:defRPr/>
+            </a:pPr>
+            <a:r>
+              <a:rPr lang="nl-NL" dirty="0"/>
+              <a:t>Demo: </a:t>
+            </a:r>
+            <a:r>
+              <a:rPr lang="en-US" sz="1200" kern="1200" dirty="0">
+                <a:solidFill>
+                  <a:schemeClr val="tx1"/>
+                </a:solidFill>
+                <a:effectLst/>
+                <a:latin typeface="+mn-lt"/>
+                <a:ea typeface="+mn-ea"/>
+                <a:cs typeface="+mn-cs"/>
+              </a:rPr>
+              <a:t>Repository unit tests</a:t>
+            </a:r>
+          </a:p>
+          <a:p>
+            <a:r>
+              <a:rPr lang="nl-NL" sz="1200" kern="1200" dirty="0">
+                <a:solidFill>
+                  <a:schemeClr val="tx1"/>
+                </a:solidFill>
+                <a:effectLst/>
+                <a:latin typeface="+mn-lt"/>
+                <a:ea typeface="+mn-ea"/>
+                <a:cs typeface="+mn-cs"/>
+              </a:rPr>
+              <a:t>Let op: zoomen kan met WIN + '+' en zoom afsluiten met WIN + </a:t>
+            </a:r>
+            <a:r>
+              <a:rPr lang="nl-NL" sz="1200" kern="1200">
+                <a:solidFill>
+                  <a:schemeClr val="tx1"/>
+                </a:solidFill>
+                <a:effectLst/>
+                <a:latin typeface="+mn-lt"/>
+                <a:ea typeface="+mn-ea"/>
+                <a:cs typeface="+mn-cs"/>
+              </a:rPr>
+              <a:t>ESC.</a:t>
+            </a:r>
+            <a:endParaRPr lang="nl-NL" sz="1200" kern="1200" dirty="0">
+              <a:solidFill>
+                <a:schemeClr val="tx1"/>
+              </a:solidFill>
+              <a:effectLst/>
+              <a:latin typeface="+mn-lt"/>
+              <a:ea typeface="+mn-ea"/>
+              <a:cs typeface="+mn-cs"/>
+            </a:endParaRPr>
           </a:p>
         </p:txBody>
       </p:sp>
@@ -2756,6 +2823,122 @@
 </file>
 
 <file path=ppt/notesSlides/notesSlide12.xml><?xml version="1.0" encoding="utf-8"?>
+<p:notes xmlns:a="http://schemas.openxmlformats.org/drawingml/2006/main" xmlns:r="http://schemas.openxmlformats.org/officeDocument/2006/relationships" xmlns:p="http://schemas.openxmlformats.org/presentationml/2006/main">
+  <p:cSld>
+    <p:spTree>
+      <p:nvGrpSpPr>
+        <p:cNvPr id="1" name=""/>
+        <p:cNvGrpSpPr/>
+        <p:nvPr/>
+      </p:nvGrpSpPr>
+      <p:grpSpPr>
+        <a:xfrm>
+          <a:off x="0" y="0"/>
+          <a:ext cx="0" cy="0"/>
+          <a:chOff x="0" y="0"/>
+          <a:chExt cx="0" cy="0"/>
+        </a:xfrm>
+      </p:grpSpPr>
+      <p:sp>
+        <p:nvSpPr>
+          <p:cNvPr id="2" name="Slide Image Placeholder 1"/>
+          <p:cNvSpPr>
+            <a:spLocks noGrp="1" noRot="1" noChangeAspect="1"/>
+          </p:cNvSpPr>
+          <p:nvPr>
+            <p:ph type="sldImg"/>
+          </p:nvPr>
+        </p:nvSpPr>
+        <p:spPr/>
+      </p:sp>
+      <p:sp>
+        <p:nvSpPr>
+          <p:cNvPr id="3" name="Notes Placeholder 2"/>
+          <p:cNvSpPr>
+            <a:spLocks noGrp="1"/>
+          </p:cNvSpPr>
+          <p:nvPr>
+            <p:ph type="body" idx="1"/>
+          </p:nvPr>
+        </p:nvSpPr>
+        <p:spPr/>
+        <p:txBody>
+          <a:bodyPr/>
+          <a:lstStyle/>
+          <a:p>
+            <a:pPr marL="0" marR="0" lvl="0" indent="0" algn="l" defTabSz="914400" rtl="0" eaLnBrk="1" fontAlgn="auto" latinLnBrk="0" hangingPunct="1">
+              <a:lnSpc>
+                <a:spcPct val="100000"/>
+              </a:lnSpc>
+              <a:spcBef>
+                <a:spcPts val="0"/>
+              </a:spcBef>
+              <a:spcAft>
+                <a:spcPts val="0"/>
+              </a:spcAft>
+              <a:buClrTx/>
+              <a:buSzTx/>
+              <a:buFontTx/>
+              <a:buNone/>
+              <a:tabLst/>
+              <a:defRPr/>
+            </a:pPr>
+            <a:r>
+              <a:rPr lang="nl-NL" dirty="0"/>
+              <a:t>Demo: </a:t>
+            </a:r>
+            <a:r>
+              <a:rPr lang="en-US" sz="1200" kern="1200" dirty="0">
+                <a:solidFill>
+                  <a:schemeClr val="tx1"/>
+                </a:solidFill>
+                <a:effectLst/>
+                <a:latin typeface="+mn-lt"/>
+                <a:ea typeface="+mn-ea"/>
+                <a:cs typeface="+mn-cs"/>
+              </a:rPr>
+              <a:t>Configuration in Core DI</a:t>
+            </a:r>
+          </a:p>
+        </p:txBody>
+      </p:sp>
+      <p:sp>
+        <p:nvSpPr>
+          <p:cNvPr id="4" name="Slide Number Placeholder 3"/>
+          <p:cNvSpPr>
+            <a:spLocks noGrp="1"/>
+          </p:cNvSpPr>
+          <p:nvPr>
+            <p:ph type="sldNum" sz="quarter" idx="5"/>
+          </p:nvPr>
+        </p:nvSpPr>
+        <p:spPr/>
+        <p:txBody>
+          <a:bodyPr/>
+          <a:lstStyle/>
+          <a:p>
+            <a:fld id="{36A6CEBA-87D9-4668-ADDB-ADABD8CF91EC}" type="slidenum">
+              <a:rPr lang="nl-NL" smtClean="0"/>
+              <a:t>16</a:t>
+            </a:fld>
+            <a:endParaRPr lang="nl-NL"/>
+          </a:p>
+        </p:txBody>
+      </p:sp>
+    </p:spTree>
+    <p:extLst>
+      <p:ext uri="{BB962C8B-B14F-4D97-AF65-F5344CB8AC3E}">
+        <p14:creationId xmlns:p14="http://schemas.microsoft.com/office/powerpoint/2010/main" val="1301050181"/>
+      </p:ext>
+    </p:extLst>
+  </p:cSld>
+  <p:clrMapOvr>
+    <a:masterClrMapping/>
+  </p:clrMapOvr>
+</p:notes>
+</file>
+
+<file path=ppt/notesSlides/notesSlide13.xml><?xml version="1.0" encoding="utf-8"?>
 <p:notes xmlns:a="http://schemas.openxmlformats.org/drawingml/2006/main" xmlns:r="http://schemas.openxmlformats.org/officeDocument/2006/relationships" xmlns:p="http://schemas.openxmlformats.org/presentationml/2006/main">
   <p:cSld>
     <p:spTree>
@@ -2839,7 +3022,7 @@
 </p:notes>
 </file>
 
-<file path=ppt/notesSlides/notesSlide13.xml><?xml version="1.0" encoding="utf-8"?>
+<file path=ppt/notesSlides/notesSlide14.xml><?xml version="1.0" encoding="utf-8"?>
 <p:notes xmlns:a="http://schemas.openxmlformats.org/drawingml/2006/main" xmlns:r="http://schemas.openxmlformats.org/officeDocument/2006/relationships" xmlns:p="http://schemas.openxmlformats.org/presentationml/2006/main">
   <p:cSld>
     <p:spTree>
@@ -2954,7 +3137,7 @@
 </p:notes>
 </file>
 
-<file path=ppt/notesSlides/notesSlide14.xml><?xml version="1.0" encoding="utf-8"?>
+<file path=ppt/notesSlides/notesSlide15.xml><?xml version="1.0" encoding="utf-8"?>
 <p:notes xmlns:a="http://schemas.openxmlformats.org/drawingml/2006/main" xmlns:r="http://schemas.openxmlformats.org/officeDocument/2006/relationships" xmlns:p="http://schemas.openxmlformats.org/presentationml/2006/main">
   <p:cSld>
     <p:spTree>
@@ -3062,7 +3245,7 @@
 </p:notes>
 </file>
 
-<file path=ppt/notesSlides/notesSlide15.xml><?xml version="1.0" encoding="utf-8"?>
+<file path=ppt/notesSlides/notesSlide16.xml><?xml version="1.0" encoding="utf-8"?>
 <p:notes xmlns:a="http://schemas.openxmlformats.org/drawingml/2006/main" xmlns:r="http://schemas.openxmlformats.org/officeDocument/2006/relationships" xmlns:p="http://schemas.openxmlformats.org/presentationml/2006/main">
   <p:cSld>
     <p:spTree>
@@ -3106,7 +3289,39 @@
           <a:bodyPr/>
           <a:lstStyle/>
           <a:p>
-            <a:endParaRPr lang="nl-NL" dirty="0"/>
+            <a:pPr marL="0" marR="0" lvl="0" indent="0" algn="l" defTabSz="914400" rtl="0" eaLnBrk="1" fontAlgn="auto" latinLnBrk="0" hangingPunct="1">
+              <a:lnSpc>
+                <a:spcPct val="100000"/>
+              </a:lnSpc>
+              <a:spcBef>
+                <a:spcPts val="0"/>
+              </a:spcBef>
+              <a:spcAft>
+                <a:spcPts val="0"/>
+              </a:spcAft>
+              <a:buClrTx/>
+              <a:buSzTx/>
+              <a:buFontTx/>
+              <a:buNone/>
+              <a:tabLst/>
+              <a:defRPr/>
+            </a:pPr>
+            <a:r>
+              <a:rPr lang="nl-NL" dirty="0"/>
+              <a:t>Demo: </a:t>
+            </a:r>
+            <a:r>
+              <a:rPr lang="en-US" sz="1200" kern="1200" dirty="0">
+                <a:solidFill>
+                  <a:schemeClr val="tx1"/>
+                </a:solidFill>
+                <a:effectLst/>
+                <a:latin typeface="+mn-lt"/>
+                <a:ea typeface="+mn-ea"/>
+                <a:cs typeface="+mn-cs"/>
+              </a:rPr>
+              <a:t>Logging in Core DI</a:t>
+            </a:r>
           </a:p>
         </p:txBody>
       </p:sp>
@@ -3146,7 +3361,7 @@
 </p:notes>
 </file>
 
-<file path=ppt/notesSlides/notesSlide16.xml><?xml version="1.0" encoding="utf-8"?>
+<file path=ppt/notesSlides/notesSlide17.xml><?xml version="1.0" encoding="utf-8"?>
 <p:notes xmlns:a="http://schemas.openxmlformats.org/drawingml/2006/main" xmlns:r="http://schemas.openxmlformats.org/officeDocument/2006/relationships" xmlns:p="http://schemas.openxmlformats.org/presentationml/2006/main">
   <p:cSld>
     <p:spTree>
@@ -3254,7 +3469,7 @@
 </p:notes>
 </file>
 
-<file path=ppt/notesSlides/notesSlide17.xml><?xml version="1.0" encoding="utf-8"?>
+<file path=ppt/notesSlides/notesSlide18.xml><?xml version="1.0" encoding="utf-8"?>
 <p:notes xmlns:a="http://schemas.openxmlformats.org/drawingml/2006/main" xmlns:r="http://schemas.openxmlformats.org/officeDocument/2006/relationships" xmlns:p="http://schemas.openxmlformats.org/presentationml/2006/main">
   <p:cSld>
     <p:spTree>
@@ -3362,7 +3577,7 @@
 </p:notes>
 </file>
 
-<file path=ppt/notesSlides/notesSlide18.xml><?xml version="1.0" encoding="utf-8"?>
+<file path=ppt/notesSlides/notesSlide19.xml><?xml version="1.0" encoding="utf-8"?>
 <p:notes xmlns:a="http://schemas.openxmlformats.org/drawingml/2006/main" xmlns:r="http://schemas.openxmlformats.org/officeDocument/2006/relationships" xmlns:p="http://schemas.openxmlformats.org/presentationml/2006/main">
   <p:cSld>
     <p:spTree>
@@ -3461,114 +3676,6 @@
     <p:extLst>
       <p:ext uri="{BB962C8B-B14F-4D97-AF65-F5344CB8AC3E}">
         <p14:creationId xmlns:p14="http://schemas.microsoft.com/office/powerpoint/2010/main" val="559301638"/>
-      </p:ext>
-    </p:extLst>
-  </p:cSld>
-  <p:clrMapOvr>
-    <a:masterClrMapping/>
-  </p:clrMapOvr>
-</p:notes>
-</file>
-
-<file path=ppt/notesSlides/notesSlide19.xml><?xml version="1.0" encoding="utf-8"?>
-<p:notes xmlns:a="http://schemas.openxmlformats.org/drawingml/2006/main" xmlns:r="http://schemas.openxmlformats.org/officeDocument/2006/relationships" xmlns:p="http://schemas.openxmlformats.org/presentationml/2006/main">
-  <p:cSld>
-    <p:spTree>
-      <p:nvGrpSpPr>
-        <p:cNvPr id="1" name="">
-          <a:extLst>
-            <a:ext uri="{FF2B5EF4-FFF2-40B4-BE49-F238E27FC236}">
-              <a16:creationId xmlns:a16="http://schemas.microsoft.com/office/drawing/2014/main" id="{03ED8F0E-FAC4-7EC5-6695-810388643B7C}"/>
-            </a:ext>
-          </a:extLst>
-        </p:cNvPr>
-        <p:cNvGrpSpPr/>
-        <p:nvPr/>
-      </p:nvGrpSpPr>
-      <p:grpSpPr>
-        <a:xfrm>
-          <a:off x="0" y="0"/>
-          <a:ext cx="0" cy="0"/>
-          <a:chOff x="0" y="0"/>
-          <a:chExt cx="0" cy="0"/>
-        </a:xfrm>
-      </p:grpSpPr>
-      <p:sp>
-        <p:nvSpPr>
-          <p:cNvPr id="2" name="Tijdelijke aanduiding voor dia-afbeelding 1">
-            <a:extLst>
-              <a:ext uri="{FF2B5EF4-FFF2-40B4-BE49-F238E27FC236}">
-                <a16:creationId xmlns:a16="http://schemas.microsoft.com/office/drawing/2014/main" id="{8139633F-4E01-2776-CDD6-77618828CEC7}"/>
-              </a:ext>
-            </a:extLst>
-          </p:cNvPr>
-          <p:cNvSpPr>
-            <a:spLocks noGrp="1" noRot="1" noChangeAspect="1"/>
-          </p:cNvSpPr>
-          <p:nvPr>
-            <p:ph type="sldImg"/>
-          </p:nvPr>
-        </p:nvSpPr>
-        <p:spPr/>
-      </p:sp>
-      <p:sp>
-        <p:nvSpPr>
-          <p:cNvPr id="3" name="Tijdelijke aanduiding voor notities 2">
-            <a:extLst>
-              <a:ext uri="{FF2B5EF4-FFF2-40B4-BE49-F238E27FC236}">
-                <a16:creationId xmlns:a16="http://schemas.microsoft.com/office/drawing/2014/main" id="{2C837011-5BAE-3462-27F2-6550F0FC85DA}"/>
-              </a:ext>
-            </a:extLst>
-          </p:cNvPr>
-          <p:cNvSpPr>
-            <a:spLocks noGrp="1"/>
-          </p:cNvSpPr>
-          <p:nvPr>
-            <p:ph type="body" idx="1"/>
-          </p:nvPr>
-        </p:nvSpPr>
-        <p:spPr/>
-        <p:txBody>
-          <a:bodyPr/>
-          <a:lstStyle/>
-          <a:p>
-            <a:endParaRPr lang="nl-NL" dirty="0"/>
-          </a:p>
-        </p:txBody>
-      </p:sp>
-      <p:sp>
-        <p:nvSpPr>
-          <p:cNvPr id="4" name="Tijdelijke aanduiding voor dianummer 3">
-            <a:extLst>
-              <a:ext uri="{FF2B5EF4-FFF2-40B4-BE49-F238E27FC236}">
-                <a16:creationId xmlns:a16="http://schemas.microsoft.com/office/drawing/2014/main" id="{3AA870E8-862D-DD51-A082-D7A13F634FD2}"/>
-              </a:ext>
-            </a:extLst>
-          </p:cNvPr>
-          <p:cNvSpPr>
-            <a:spLocks noGrp="1"/>
-          </p:cNvSpPr>
-          <p:nvPr>
-            <p:ph type="sldNum" sz="quarter" idx="5"/>
-          </p:nvPr>
-        </p:nvSpPr>
-        <p:spPr/>
-        <p:txBody>
-          <a:bodyPr/>
-          <a:lstStyle/>
-          <a:p>
-            <a:fld id="{36A6CEBA-87D9-4668-ADDB-ADABD8CF91EC}" type="slidenum">
-              <a:rPr lang="nl-NL" smtClean="0"/>
-              <a:t>24</a:t>
-            </a:fld>
-            <a:endParaRPr lang="nl-NL"/>
-          </a:p>
-        </p:txBody>
-      </p:sp>
-    </p:spTree>
-    <p:extLst>
-      <p:ext uri="{BB962C8B-B14F-4D97-AF65-F5344CB8AC3E}">
-        <p14:creationId xmlns:p14="http://schemas.microsoft.com/office/powerpoint/2010/main" val="888765944"/>
       </p:ext>
     </p:extLst>
   </p:cSld>
@@ -3670,6 +3777,114 @@
         <p:cNvPr id="1" name="">
           <a:extLst>
             <a:ext uri="{FF2B5EF4-FFF2-40B4-BE49-F238E27FC236}">
+              <a16:creationId xmlns:a16="http://schemas.microsoft.com/office/drawing/2014/main" id="{03ED8F0E-FAC4-7EC5-6695-810388643B7C}"/>
+            </a:ext>
+          </a:extLst>
+        </p:cNvPr>
+        <p:cNvGrpSpPr/>
+        <p:nvPr/>
+      </p:nvGrpSpPr>
+      <p:grpSpPr>
+        <a:xfrm>
+          <a:off x="0" y="0"/>
+          <a:ext cx="0" cy="0"/>
+          <a:chOff x="0" y="0"/>
+          <a:chExt cx="0" cy="0"/>
+        </a:xfrm>
+      </p:grpSpPr>
+      <p:sp>
+        <p:nvSpPr>
+          <p:cNvPr id="2" name="Tijdelijke aanduiding voor dia-afbeelding 1">
+            <a:extLst>
+              <a:ext uri="{FF2B5EF4-FFF2-40B4-BE49-F238E27FC236}">
+                <a16:creationId xmlns:a16="http://schemas.microsoft.com/office/drawing/2014/main" id="{8139633F-4E01-2776-CDD6-77618828CEC7}"/>
+              </a:ext>
+            </a:extLst>
+          </p:cNvPr>
+          <p:cNvSpPr>
+            <a:spLocks noGrp="1" noRot="1" noChangeAspect="1"/>
+          </p:cNvSpPr>
+          <p:nvPr>
+            <p:ph type="sldImg"/>
+          </p:nvPr>
+        </p:nvSpPr>
+        <p:spPr/>
+      </p:sp>
+      <p:sp>
+        <p:nvSpPr>
+          <p:cNvPr id="3" name="Tijdelijke aanduiding voor notities 2">
+            <a:extLst>
+              <a:ext uri="{FF2B5EF4-FFF2-40B4-BE49-F238E27FC236}">
+                <a16:creationId xmlns:a16="http://schemas.microsoft.com/office/drawing/2014/main" id="{2C837011-5BAE-3462-27F2-6550F0FC85DA}"/>
+              </a:ext>
+            </a:extLst>
+          </p:cNvPr>
+          <p:cNvSpPr>
+            <a:spLocks noGrp="1"/>
+          </p:cNvSpPr>
+          <p:nvPr>
+            <p:ph type="body" idx="1"/>
+          </p:nvPr>
+        </p:nvSpPr>
+        <p:spPr/>
+        <p:txBody>
+          <a:bodyPr/>
+          <a:lstStyle/>
+          <a:p>
+            <a:endParaRPr lang="nl-NL" dirty="0"/>
+          </a:p>
+        </p:txBody>
+      </p:sp>
+      <p:sp>
+        <p:nvSpPr>
+          <p:cNvPr id="4" name="Tijdelijke aanduiding voor dianummer 3">
+            <a:extLst>
+              <a:ext uri="{FF2B5EF4-FFF2-40B4-BE49-F238E27FC236}">
+                <a16:creationId xmlns:a16="http://schemas.microsoft.com/office/drawing/2014/main" id="{3AA870E8-862D-DD51-A082-D7A13F634FD2}"/>
+              </a:ext>
+            </a:extLst>
+          </p:cNvPr>
+          <p:cNvSpPr>
+            <a:spLocks noGrp="1"/>
+          </p:cNvSpPr>
+          <p:nvPr>
+            <p:ph type="sldNum" sz="quarter" idx="5"/>
+          </p:nvPr>
+        </p:nvSpPr>
+        <p:spPr/>
+        <p:txBody>
+          <a:bodyPr/>
+          <a:lstStyle/>
+          <a:p>
+            <a:fld id="{36A6CEBA-87D9-4668-ADDB-ADABD8CF91EC}" type="slidenum">
+              <a:rPr lang="nl-NL" smtClean="0"/>
+              <a:t>24</a:t>
+            </a:fld>
+            <a:endParaRPr lang="nl-NL"/>
+          </a:p>
+        </p:txBody>
+      </p:sp>
+    </p:spTree>
+    <p:extLst>
+      <p:ext uri="{BB962C8B-B14F-4D97-AF65-F5344CB8AC3E}">
+        <p14:creationId xmlns:p14="http://schemas.microsoft.com/office/powerpoint/2010/main" val="888765944"/>
+      </p:ext>
+    </p:extLst>
+  </p:cSld>
+  <p:clrMapOvr>
+    <a:masterClrMapping/>
+  </p:clrMapOvr>
+</p:notes>
+</file>
+
+<file path=ppt/notesSlides/notesSlide21.xml><?xml version="1.0" encoding="utf-8"?>
+<p:notes xmlns:a="http://schemas.openxmlformats.org/drawingml/2006/main" xmlns:r="http://schemas.openxmlformats.org/officeDocument/2006/relationships" xmlns:p="http://schemas.openxmlformats.org/presentationml/2006/main">
+  <p:cSld>
+    <p:spTree>
+      <p:nvGrpSpPr>
+        <p:cNvPr id="1" name="">
+          <a:extLst>
+            <a:ext uri="{FF2B5EF4-FFF2-40B4-BE49-F238E27FC236}">
               <a16:creationId xmlns:a16="http://schemas.microsoft.com/office/drawing/2014/main" id="{736F6A46-970B-C4A6-AB7C-EB041A23CA74}"/>
             </a:ext>
           </a:extLst>
@@ -3724,7 +3939,18 @@
           <a:bodyPr/>
           <a:lstStyle/>
           <a:p>
-            <a:endParaRPr lang="nl-NL" dirty="0"/>
+            <a:r>
+              <a:rPr lang="en-US" sz="1200" kern="1200" dirty="0">
+                <a:solidFill>
+                  <a:schemeClr val="tx1"/>
+                </a:solidFill>
+                <a:effectLst/>
+                <a:latin typeface="+mn-lt"/>
+                <a:ea typeface="+mn-ea"/>
+                <a:cs typeface="+mn-cs"/>
+              </a:rPr>
+              <a:t>Demo: In depth Core DI</a:t>
+            </a:r>
           </a:p>
         </p:txBody>
       </p:sp>
@@ -3770,7 +3996,7 @@
 </p:notes>
 </file>
 
-<file path=ppt/notesSlides/notesSlide21.xml><?xml version="1.0" encoding="utf-8"?>
+<file path=ppt/notesSlides/notesSlide22.xml><?xml version="1.0" encoding="utf-8"?>
 <p:notes xmlns:a="http://schemas.openxmlformats.org/drawingml/2006/main" xmlns:r="http://schemas.openxmlformats.org/officeDocument/2006/relationships" xmlns:p="http://schemas.openxmlformats.org/presentationml/2006/main">
   <p:cSld>
     <p:spTree>
@@ -4225,6 +4451,77 @@
               <a:t>.</a:t>
             </a:r>
           </a:p>
+          <a:p>
+            <a:pPr marL="0" marR="0" lvl="0" indent="0" algn="l" defTabSz="914400" rtl="0" eaLnBrk="1" fontAlgn="auto" latinLnBrk="0" hangingPunct="1">
+              <a:lnSpc>
+                <a:spcPct val="100000"/>
+              </a:lnSpc>
+              <a:spcBef>
+                <a:spcPts val="0"/>
+              </a:spcBef>
+              <a:spcAft>
+                <a:spcPts val="0"/>
+              </a:spcAft>
+              <a:buClrTx/>
+              <a:buSzTx/>
+              <a:buFontTx/>
+              <a:buNone/>
+              <a:tabLst/>
+              <a:defRPr/>
+            </a:pPr>
+            <a:r>
+              <a:rPr lang="nl-NL" dirty="0"/>
+              <a:t>Demo: </a:t>
+            </a:r>
+            <a:r>
+              <a:rPr lang="en-US" sz="1200" kern="1200" dirty="0" err="1">
+                <a:solidFill>
+                  <a:schemeClr val="tx1"/>
+                </a:solidFill>
+                <a:effectLst/>
+                <a:latin typeface="+mn-lt"/>
+                <a:ea typeface="+mn-ea"/>
+                <a:cs typeface="+mn-cs"/>
+              </a:rPr>
+              <a:t>Eerste</a:t>
+            </a:r>
+            <a:r>
+              <a:rPr lang="en-US" sz="1200" kern="1200" dirty="0">
+                <a:solidFill>
+                  <a:schemeClr val="tx1"/>
+                </a:solidFill>
+                <a:effectLst/>
+                <a:latin typeface="+mn-lt"/>
+                <a:ea typeface="+mn-ea"/>
+                <a:cs typeface="+mn-cs"/>
+              </a:rPr>
+              <a:t> </a:t>
+            </a:r>
+            <a:r>
+              <a:rPr lang="en-US" sz="1200" kern="1200" dirty="0" err="1">
+                <a:solidFill>
+                  <a:schemeClr val="tx1"/>
+                </a:solidFill>
+                <a:effectLst/>
+                <a:latin typeface="+mn-lt"/>
+                <a:ea typeface="+mn-ea"/>
+                <a:cs typeface="+mn-cs"/>
+              </a:rPr>
+              <a:t>stappen</a:t>
+            </a:r>
+            <a:r>
+              <a:rPr lang="en-US" sz="1200" kern="1200" dirty="0">
+                <a:solidFill>
+                  <a:schemeClr val="tx1"/>
+                </a:solidFill>
+                <a:effectLst/>
+                <a:latin typeface="+mn-lt"/>
+                <a:ea typeface="+mn-ea"/>
+                <a:cs typeface="+mn-cs"/>
+              </a:rPr>
+              <a:t> Core DI</a:t>
+            </a:r>
+          </a:p>
         </p:txBody>
       </p:sp>
       <p:sp>
@@ -4508,6 +4805,77 @@
         <p:txBody>
           <a:bodyPr/>
           <a:lstStyle/>
+          <a:p>
+            <a:pPr marL="0" marR="0" lvl="0" indent="0" algn="l" defTabSz="914400" rtl="0" eaLnBrk="1" fontAlgn="auto" latinLnBrk="0" hangingPunct="1">
+              <a:lnSpc>
+                <a:spcPct val="100000"/>
+              </a:lnSpc>
+              <a:spcBef>
+                <a:spcPts val="0"/>
+              </a:spcBef>
+              <a:spcAft>
+                <a:spcPts val="0"/>
+              </a:spcAft>
+              <a:buClrTx/>
+              <a:buSzTx/>
+              <a:buFontTx/>
+              <a:buNone/>
+              <a:tabLst/>
+              <a:defRPr/>
+            </a:pPr>
+            <a:r>
+              <a:rPr lang="nl-NL" dirty="0"/>
+              <a:t>Demo: </a:t>
+            </a:r>
+            <a:r>
+              <a:rPr lang="en-US" sz="1200" kern="1200" dirty="0" err="1">
+                <a:solidFill>
+                  <a:schemeClr val="tx1"/>
+                </a:solidFill>
+                <a:effectLst/>
+                <a:latin typeface="+mn-lt"/>
+                <a:ea typeface="+mn-ea"/>
+                <a:cs typeface="+mn-cs"/>
+              </a:rPr>
+              <a:t>PersonBC</a:t>
+            </a:r>
+            <a:r>
+              <a:rPr lang="en-US" sz="1200" kern="1200" dirty="0">
+                <a:solidFill>
+                  <a:schemeClr val="tx1"/>
+                </a:solidFill>
+                <a:effectLst/>
+                <a:latin typeface="+mn-lt"/>
+                <a:ea typeface="+mn-ea"/>
+                <a:cs typeface="+mn-cs"/>
+              </a:rPr>
+              <a:t> &amp; </a:t>
+            </a:r>
+            <a:r>
+              <a:rPr lang="en-US" sz="1200" kern="1200" dirty="0" err="1">
+                <a:solidFill>
+                  <a:schemeClr val="tx1"/>
+                </a:solidFill>
+                <a:effectLst/>
+                <a:latin typeface="+mn-lt"/>
+                <a:ea typeface="+mn-ea"/>
+                <a:cs typeface="+mn-cs"/>
+              </a:rPr>
+              <a:t>CrmValidations</a:t>
+            </a:r>
+            <a:r>
+              <a:rPr lang="en-US" sz="1200" kern="1200" dirty="0">
+                <a:solidFill>
+                  <a:schemeClr val="tx1"/>
+                </a:solidFill>
+                <a:effectLst/>
+                <a:latin typeface="+mn-lt"/>
+                <a:ea typeface="+mn-ea"/>
+                <a:cs typeface="+mn-cs"/>
+              </a:rPr>
+              <a:t> unit tests</a:t>
+            </a:r>
+          </a:p>
           <a:p>
             <a:endParaRPr lang="nl-NL" dirty="0"/>
           </a:p>
@@ -20025,7 +20393,7 @@
           <p:nvPr/>
         </p:nvPicPr>
         <p:blipFill>
-          <a:blip r:embed="rId2">
+          <a:blip r:embed="rId3">
             <a:extLst>
               <a:ext uri="{28A0092B-C50C-407E-A947-70E740481C1C}">
                 <a14:useLocalDpi xmlns:a14="http://schemas.microsoft.com/office/drawing/2010/main" val="0"/>
@@ -23268,6 +23636,53 @@
           </a:p>
         </p:txBody>
       </p:sp>
+      <p:pic>
+        <p:nvPicPr>
+          <p:cNvPr id="2" name="Picture 2" descr="Live demo @ the staff club, Highfield - Digital Learning">
+            <a:extLst>
+              <a:ext uri="{FF2B5EF4-FFF2-40B4-BE49-F238E27FC236}">
+                <a16:creationId xmlns:a16="http://schemas.microsoft.com/office/drawing/2014/main" id="{44BB710C-78C9-CE28-EEB2-0914DDB5F975}"/>
+              </a:ext>
+            </a:extLst>
+          </p:cNvPr>
+          <p:cNvPicPr>
+            <a:picLocks noChangeAspect="1" noChangeArrowheads="1"/>
+          </p:cNvPicPr>
+          <p:nvPr/>
+        </p:nvPicPr>
+        <p:blipFill>
+          <a:blip r:embed="rId3">
+            <a:extLst>
+              <a:ext uri="{28A0092B-C50C-407E-A947-70E740481C1C}">
+                <a14:useLocalDpi xmlns:a14="http://schemas.microsoft.com/office/drawing/2010/main" val="0"/>
+              </a:ext>
+            </a:extLst>
+          </a:blip>
+          <a:srcRect/>
+          <a:stretch>
+            <a:fillRect/>
+          </a:stretch>
+        </p:blipFill>
+        <p:spPr bwMode="auto">
+          <a:xfrm>
+            <a:off x="10313575" y="5887844"/>
+            <a:ext cx="1878425" cy="781500"/>
+          </a:xfrm>
+          <a:prstGeom prst="rect">
+            <a:avLst/>
+          </a:prstGeom>
+          <a:noFill/>
+          <a:extLst>
+            <a:ext uri="{909E8E84-426E-40DD-AFC4-6F175D3DCCD1}">
+              <a14:hiddenFill xmlns:a14="http://schemas.microsoft.com/office/drawing/2010/main">
+                <a:solidFill>
+                  <a:srgbClr val="FFFFFF"/>
+                </a:solidFill>
+              </a14:hiddenFill>
+            </a:ext>
+          </a:extLst>
+        </p:spPr>
+      </p:pic>
     </p:spTree>
     <p:extLst>
       <p:ext uri="{BB962C8B-B14F-4D97-AF65-F5344CB8AC3E}">

</xml_diff>